<commit_message>
Standardise slide headers on CQC content layout in PPTX templates
Convert the 'Programme Yellow' slides in the Architecture Options and
Vision paper templates to the standard 'Title & Content' header
(rounded purple band + CQC logo top-right), matching the rest of each
deck. Titles set to the canonical master title position; the body
textbox (Options slide 5) and table (Vision slide 9) nudged below the
header band. Minimal, surgical XML edits — no full re-save.

Co-Authored-By: Claude Opus 4.8 (1M context) <noreply@anthropic.com>
</commit_message>
<xml_diff>
--- a/Finalised Templates/PowerPoint/Architecture_Vision_Paper_Template.pptx
+++ b/Finalised Templates/PowerPoint/Architecture_Vision_Paper_Template.pptx
@@ -20155,8 +20155,8 @@
         </p:nvSpPr>
         <p:spPr>
           <a:xfrm>
-            <a:off x="225232" y="5137"/>
-            <a:ext cx="10246784" cy="906463"/>
+            <a:off x="863601" y="209749"/>
+            <a:ext cx="7437967" cy="906463"/>
           </a:xfrm>
         </p:spPr>
         <p:txBody>
@@ -20203,7 +20203,7 @@
           </p:nvPr>
         </p:nvGraphicFramePr>
         <p:xfrm>
-          <a:off x="65170" y="1219156"/>
+          <a:off x="65170" y="1260001"/>
           <a:ext cx="11572648" cy="5057533"/>
         </p:xfrm>
         <a:graphic>
@@ -20891,8 +20891,8 @@
         </p:nvSpPr>
         <p:spPr>
           <a:xfrm>
-            <a:off x="127628" y="53844"/>
-            <a:ext cx="10246784" cy="906463"/>
+            <a:off x="863601" y="209749"/>
+            <a:ext cx="7437967" cy="906463"/>
           </a:xfrm>
         </p:spPr>
         <p:txBody>
@@ -21288,8 +21288,8 @@
         </p:nvSpPr>
         <p:spPr>
           <a:xfrm>
-            <a:off x="127628" y="53844"/>
-            <a:ext cx="10246784" cy="906463"/>
+            <a:off x="863601" y="209749"/>
+            <a:ext cx="7437967" cy="906463"/>
           </a:xfrm>
         </p:spPr>
         <p:txBody>
@@ -21685,8 +21685,8 @@
         </p:nvSpPr>
         <p:spPr>
           <a:xfrm>
-            <a:off x="127628" y="53844"/>
-            <a:ext cx="10246784" cy="906463"/>
+            <a:off x="863601" y="209749"/>
+            <a:ext cx="7437967" cy="906463"/>
           </a:xfrm>
         </p:spPr>
         <p:txBody>
@@ -26219,8 +26219,8 @@
         </p:nvSpPr>
         <p:spPr>
           <a:xfrm>
-            <a:off x="127628" y="53844"/>
-            <a:ext cx="10246784" cy="906463"/>
+            <a:off x="863601" y="209749"/>
+            <a:ext cx="7437967" cy="906463"/>
           </a:xfrm>
         </p:spPr>
         <p:txBody>
@@ -26594,8 +26594,8 @@
         </p:nvSpPr>
         <p:spPr>
           <a:xfrm>
-            <a:off x="127628" y="53844"/>
-            <a:ext cx="10246784" cy="906463"/>
+            <a:off x="863601" y="209749"/>
+            <a:ext cx="7437967" cy="906463"/>
           </a:xfrm>
         </p:spPr>
         <p:txBody>
@@ -27075,8 +27075,8 @@
         </p:nvSpPr>
         <p:spPr>
           <a:xfrm>
-            <a:off x="127628" y="53844"/>
-            <a:ext cx="10246784" cy="906463"/>
+            <a:off x="863601" y="209749"/>
+            <a:ext cx="7437967" cy="906463"/>
           </a:xfrm>
         </p:spPr>
         <p:txBody>
@@ -27556,8 +27556,8 @@
         </p:nvSpPr>
         <p:spPr>
           <a:xfrm>
-            <a:off x="127628" y="53844"/>
-            <a:ext cx="10246784" cy="906463"/>
+            <a:off x="863601" y="209749"/>
+            <a:ext cx="7437967" cy="906463"/>
           </a:xfrm>
         </p:spPr>
         <p:txBody>
@@ -28077,8 +28077,8 @@
         </p:nvSpPr>
         <p:spPr>
           <a:xfrm>
-            <a:off x="127628" y="53844"/>
-            <a:ext cx="10246784" cy="906463"/>
+            <a:off x="863601" y="209749"/>
+            <a:ext cx="7437967" cy="906463"/>
           </a:xfrm>
         </p:spPr>
         <p:txBody>
@@ -37735,8 +37735,8 @@
         </p:nvSpPr>
         <p:spPr>
           <a:xfrm>
-            <a:off x="127628" y="53844"/>
-            <a:ext cx="10246784" cy="906463"/>
+            <a:off x="863601" y="209749"/>
+            <a:ext cx="7437967" cy="906463"/>
           </a:xfrm>
         </p:spPr>
         <p:txBody>

</xml_diff>